<commit_message>
docs(deck): add class-weighting decision to the modeling slide
Spell out the imbalance handling: weight the minority class ~7.8x in the loss
(scale_pos_weight = negatives / positives), not resampling.

Co-Authored-By: Claude Opus 4.8 <noreply@anthropic.com>
</commit_message>
<xml_diff>
--- a/presentation/readmission_demo.pptx
+++ b/presentation/readmission_demo.pptx
@@ -5971,8 +5971,8 @@
         </p:nvSpPr>
         <p:spPr>
           <a:xfrm>
-            <a:off x="548640" y="1097280"/>
-            <a:ext cx="11064240" cy="1463040"/>
+            <a:off x="548640" y="1051560"/>
+            <a:ext cx="11064240" cy="1600200"/>
           </a:xfrm>
           <a:prstGeom prst="rect">
             <a:avLst/>
@@ -6002,16 +6002,31 @@
           <a:p>
             <a:pPr algn="l">
               <a:spcAft>
+                <a:spcPts val="500"/>
+              </a:spcAft>
+              <a:defRPr sz="1400" b="0">
+                <a:solidFill>
+                  <a:srgbClr val="16261D"/>
+                </a:solidFill>
+              </a:defRPr>
+            </a:pPr>
+            <a:r>
+              <a:t>Split by patient (no leakage) · tune on PR-AUC · calibrate probabilities · cost-based threshold (0.10).</a:t>
+            </a:r>
+          </a:p>
+          <a:p>
+            <a:pPr algn="l">
+              <a:spcAft>
                 <a:spcPts val="600"/>
               </a:spcAft>
-              <a:defRPr sz="1400" b="0">
-                <a:solidFill>
-                  <a:srgbClr val="16261D"/>
-                </a:solidFill>
-              </a:defRPr>
-            </a:pPr>
-            <a:r>
-              <a:t>Split by patient (no leakage) · class weights, not resampling · tune on PR-AUC · calibrate probabilities · cost-based threshold.</a:t>
+              <a:defRPr sz="1300" b="0">
+                <a:solidFill>
+                  <a:srgbClr val="5A6F63"/>
+                </a:solidFill>
+              </a:defRPr>
+            </a:pPr>
+            <a:r>
+              <a:t>Handle 11% imbalance by weighting the minority class ≈7.8× in the loss (scale_pos_weight = negatives ÷ positives = 61,698 ÷ 7,915) — not resampling, which would duplicate patients and break grouped CV.</a:t>
             </a:r>
           </a:p>
         </p:txBody>

</xml_diff>

<commit_message>
docs(deck): faithful two-plane architecture slide + class weighting
Architecture slide redrawn natively (landscape): offline pipeline (raw →
cleaned → features → splits → registry) → artifacts bridge → online serve,
with the Monitoring & Governance band beneath — mirrors docs/ARCHITECTURE.md.
Modeling slide states the ~7.8x minority-class weighting.

Co-Authored-By: Claude Opus 4.8 <noreply@anthropic.com>
</commit_message>
<xml_diff>
--- a/presentation/readmission_demo.pptx
+++ b/presentation/readmission_demo.pptx
@@ -4189,14 +4189,52 @@
       </p:sp>
       <p:sp>
         <p:nvSpPr>
-          <p:cNvPr id="3" name="Rounded Rectangle 2"/>
+          <p:cNvPr id="3" name="TextBox 2"/>
+          <p:cNvSpPr txBox="1"/>
+          <p:nvPr/>
+        </p:nvSpPr>
+        <p:spPr>
+          <a:xfrm>
+            <a:off x="530352" y="960120"/>
+            <a:ext cx="7315200" cy="292608"/>
+          </a:xfrm>
+          <a:prstGeom prst="rect">
+            <a:avLst/>
+          </a:prstGeom>
+          <a:noFill/>
+        </p:spPr>
+        <p:txBody>
+          <a:bodyPr wrap="square" anchor="t">
+            <a:spAutoFit/>
+          </a:bodyPr>
+          <a:lstStyle/>
+          <a:p>
+            <a:pPr algn="l">
+              <a:spcAft>
+                <a:spcPts val="600"/>
+              </a:spcAft>
+              <a:defRPr sz="1300" b="1">
+                <a:solidFill>
+                  <a:srgbClr val="0B6B4F"/>
+                </a:solidFill>
+              </a:defRPr>
+            </a:pPr>
+            <a:r>
+              <a:t>OFFLINE  —  build pipeline  (dvc repro → MLflow)</a:t>
+            </a:r>
+          </a:p>
+        </p:txBody>
+      </p:sp>
+      <p:sp>
+        <p:nvSpPr>
+          <p:cNvPr id="4" name="Rounded Rectangle 3"/>
           <p:cNvSpPr/>
           <p:nvPr/>
         </p:nvSpPr>
         <p:spPr>
           <a:xfrm>
-            <a:off x="504291" y="1783080"/>
-            <a:ext cx="1627632" cy="1143000"/>
+            <a:off x="527151" y="1325880"/>
+            <a:ext cx="1993392" cy="868680"/>
           </a:xfrm>
           <a:prstGeom prst="roundRect">
             <a:avLst/>
@@ -4229,9 +4267,9 @@
           <a:p>
             <a:pPr algn="ctr">
               <a:spcAft>
-                <a:spcPts val="200"/>
-              </a:spcAft>
-              <a:defRPr sz="1400" b="1">
+                <a:spcPts val="100"/>
+              </a:spcAft>
+              <a:defRPr sz="1300" b="1">
                 <a:solidFill>
                   <a:srgbClr val="FFFFFF"/>
                 </a:solidFill>
@@ -4246,28 +4284,28 @@
               <a:spcAft>
                 <a:spcPts val="0"/>
               </a:spcAft>
-              <a:defRPr sz="1000" b="0">
+              <a:defRPr sz="950" b="0">
                 <a:solidFill>
                   <a:srgbClr val="CFE6D8"/>
                 </a:solidFill>
               </a:defRPr>
             </a:pPr>
             <a:r>
-              <a:t>101k encounters</a:t>
-            </a:r>
-          </a:p>
-        </p:txBody>
-      </p:sp>
-      <p:sp>
-        <p:nvSpPr>
-          <p:cNvPr id="4" name="Rounded Rectangle 3"/>
+              <a:t>diabetic_data.csv</a:t>
+            </a:r>
+          </a:p>
+        </p:txBody>
+      </p:sp>
+      <p:sp>
+        <p:nvSpPr>
+          <p:cNvPr id="5" name="Rounded Rectangle 4"/>
           <p:cNvSpPr/>
           <p:nvPr/>
         </p:nvSpPr>
         <p:spPr>
           <a:xfrm>
-            <a:off x="2415387" y="1783080"/>
-            <a:ext cx="1627632" cy="1143000"/>
+            <a:off x="2813151" y="1325880"/>
+            <a:ext cx="1993392" cy="868680"/>
           </a:xfrm>
           <a:prstGeom prst="roundRect">
             <a:avLst/>
@@ -4300,9 +4338,9 @@
           <a:p>
             <a:pPr algn="ctr">
               <a:spcAft>
-                <a:spcPts val="200"/>
-              </a:spcAft>
-              <a:defRPr sz="1400" b="1">
+                <a:spcPts val="100"/>
+              </a:spcAft>
+              <a:defRPr sz="1300" b="1">
                 <a:solidFill>
                   <a:srgbClr val="FFFFFF"/>
                 </a:solidFill>
@@ -4317,28 +4355,28 @@
               <a:spcAft>
                 <a:spcPts val="0"/>
               </a:spcAft>
-              <a:defRPr sz="1000" b="0">
+              <a:defRPr sz="950" b="0">
                 <a:solidFill>
                   <a:srgbClr val="CFE6D8"/>
                 </a:solidFill>
               </a:defRPr>
             </a:pPr>
             <a:r>
-              <a:t>? → NaN, filter</a:t>
-            </a:r>
-          </a:p>
-        </p:txBody>
-      </p:sp>
-      <p:sp>
-        <p:nvSpPr>
-          <p:cNvPr id="5" name="Rounded Rectangle 4"/>
+              <a:t>cleaned.parquet</a:t>
+            </a:r>
+          </a:p>
+        </p:txBody>
+      </p:sp>
+      <p:sp>
+        <p:nvSpPr>
+          <p:cNvPr id="6" name="Rounded Rectangle 5"/>
           <p:cNvSpPr/>
           <p:nvPr/>
         </p:nvSpPr>
         <p:spPr>
           <a:xfrm>
-            <a:off x="4326483" y="1783080"/>
-            <a:ext cx="1627632" cy="1143000"/>
+            <a:off x="5099151" y="1325880"/>
+            <a:ext cx="1993392" cy="868680"/>
           </a:xfrm>
           <a:prstGeom prst="roundRect">
             <a:avLst/>
@@ -4371,9 +4409,9 @@
           <a:p>
             <a:pPr algn="ctr">
               <a:spcAft>
-                <a:spcPts val="200"/>
-              </a:spcAft>
-              <a:defRPr sz="1400" b="1">
+                <a:spcPts val="100"/>
+              </a:spcAft>
+              <a:defRPr sz="1300" b="1">
                 <a:solidFill>
                   <a:srgbClr val="FFFFFF"/>
                 </a:solidFill>
@@ -4388,28 +4426,28 @@
               <a:spcAft>
                 <a:spcPts val="0"/>
               </a:spcAft>
-              <a:defRPr sz="1000" b="0">
+              <a:defRPr sz="950" b="0">
                 <a:solidFill>
                   <a:srgbClr val="CFE6D8"/>
                 </a:solidFill>
               </a:defRPr>
             </a:pPr>
             <a:r>
-              <a:t>engineer() · 48</a:t>
-            </a:r>
-          </a:p>
-        </p:txBody>
-      </p:sp>
-      <p:sp>
-        <p:nvSpPr>
-          <p:cNvPr id="6" name="Rounded Rectangle 5"/>
+              <a:t>features.parquet · 48</a:t>
+            </a:r>
+          </a:p>
+        </p:txBody>
+      </p:sp>
+      <p:sp>
+        <p:nvSpPr>
+          <p:cNvPr id="7" name="Rounded Rectangle 6"/>
           <p:cNvSpPr/>
           <p:nvPr/>
         </p:nvSpPr>
         <p:spPr>
           <a:xfrm>
-            <a:off x="6237579" y="1783080"/>
-            <a:ext cx="1627632" cy="1143000"/>
+            <a:off x="7385151" y="1325880"/>
+            <a:ext cx="1993392" cy="868680"/>
           </a:xfrm>
           <a:prstGeom prst="roundRect">
             <a:avLst/>
@@ -4442,16 +4480,16 @@
           <a:p>
             <a:pPr algn="ctr">
               <a:spcAft>
-                <a:spcPts val="200"/>
-              </a:spcAft>
-              <a:defRPr sz="1400" b="1">
+                <a:spcPts val="100"/>
+              </a:spcAft>
+              <a:defRPr sz="1300" b="1">
                 <a:solidFill>
                   <a:srgbClr val="FFFFFF"/>
                 </a:solidFill>
               </a:defRPr>
             </a:pPr>
             <a:r>
-              <a:t>Train &amp; select</a:t>
+              <a:t>Train + select</a:t>
             </a:r>
           </a:p>
           <a:p>
@@ -4459,28 +4497,28 @@
               <a:spcAft>
                 <a:spcPts val="0"/>
               </a:spcAft>
-              <a:defRPr sz="1000" b="0">
+              <a:defRPr sz="950" b="0">
                 <a:solidFill>
                   <a:srgbClr val="CFE6D8"/>
                 </a:solidFill>
               </a:defRPr>
             </a:pPr>
             <a:r>
-              <a:t>XGB winner</a:t>
-            </a:r>
-          </a:p>
-        </p:txBody>
-      </p:sp>
-      <p:sp>
-        <p:nvSpPr>
-          <p:cNvPr id="7" name="Rounded Rectangle 6"/>
+              <a:t>XGB · LGBM · LR</a:t>
+            </a:r>
+          </a:p>
+        </p:txBody>
+      </p:sp>
+      <p:sp>
+        <p:nvSpPr>
+          <p:cNvPr id="8" name="Rounded Rectangle 7"/>
           <p:cNvSpPr/>
           <p:nvPr/>
         </p:nvSpPr>
         <p:spPr>
           <a:xfrm>
-            <a:off x="8148675" y="1783080"/>
-            <a:ext cx="1627632" cy="1143000"/>
+            <a:off x="9671151" y="1325880"/>
+            <a:ext cx="1993392" cy="868680"/>
           </a:xfrm>
           <a:prstGeom prst="roundRect">
             <a:avLst/>
@@ -4513,16 +4551,16 @@
           <a:p>
             <a:pPr algn="ctr">
               <a:spcAft>
-                <a:spcPts val="200"/>
-              </a:spcAft>
-              <a:defRPr sz="1400" b="1">
+                <a:spcPts val="100"/>
+              </a:spcAft>
+              <a:defRPr sz="1300" b="1">
                 <a:solidFill>
                   <a:srgbClr val="FFFFFF"/>
                 </a:solidFill>
               </a:defRPr>
             </a:pPr>
             <a:r>
-              <a:t>Export</a:t>
+              <a:t>Registry</a:t>
             </a:r>
           </a:p>
           <a:p>
@@ -4530,28 +4568,426 @@
               <a:spcAft>
                 <a:spcPts val="0"/>
               </a:spcAft>
-              <a:defRPr sz="1000" b="0">
+              <a:defRPr sz="950" b="0">
                 <a:solidFill>
                   <a:srgbClr val="CFE6D8"/>
                 </a:solidFill>
               </a:defRPr>
             </a:pPr>
             <a:r>
-              <a:t>model + spec</a:t>
-            </a:r>
-          </a:p>
-        </p:txBody>
-      </p:sp>
-      <p:sp>
-        <p:nvSpPr>
-          <p:cNvPr id="8" name="Rounded Rectangle 7"/>
+              <a:t>model vN</a:t>
+            </a:r>
+          </a:p>
+        </p:txBody>
+      </p:sp>
+      <p:sp>
+        <p:nvSpPr>
+          <p:cNvPr id="9" name="Right Arrow 8"/>
           <p:cNvSpPr/>
           <p:nvPr/>
         </p:nvSpPr>
         <p:spPr>
           <a:xfrm>
-            <a:off x="10059771" y="1783080"/>
-            <a:ext cx="1627632" cy="1143000"/>
+            <a:off x="2538831" y="1668779"/>
+            <a:ext cx="256032" cy="182880"/>
+          </a:xfrm>
+          <a:prstGeom prst="rightArrow">
+            <a:avLst/>
+          </a:prstGeom>
+          <a:solidFill>
+            <a:srgbClr val="074D39"/>
+          </a:solidFill>
+          <a:ln>
+            <a:noFill/>
+          </a:ln>
+          <a:effectLst/>
+        </p:spPr>
+        <p:style>
+          <a:lnRef idx="1">
+            <a:schemeClr val="accent1"/>
+          </a:lnRef>
+          <a:fillRef idx="3">
+            <a:schemeClr val="accent1"/>
+          </a:fillRef>
+          <a:effectRef idx="2">
+            <a:schemeClr val="accent1"/>
+          </a:effectRef>
+          <a:fontRef idx="minor">
+            <a:schemeClr val="lt1"/>
+          </a:fontRef>
+        </p:style>
+        <p:txBody>
+          <a:bodyPr rtlCol="0" anchor="ctr"/>
+          <a:lstStyle/>
+          <a:p>
+            <a:pPr algn="ctr"/>
+          </a:p>
+        </p:txBody>
+      </p:sp>
+      <p:sp>
+        <p:nvSpPr>
+          <p:cNvPr id="10" name="Right Arrow 9"/>
+          <p:cNvSpPr/>
+          <p:nvPr/>
+        </p:nvSpPr>
+        <p:spPr>
+          <a:xfrm>
+            <a:off x="4824831" y="1668779"/>
+            <a:ext cx="256032" cy="182880"/>
+          </a:xfrm>
+          <a:prstGeom prst="rightArrow">
+            <a:avLst/>
+          </a:prstGeom>
+          <a:solidFill>
+            <a:srgbClr val="074D39"/>
+          </a:solidFill>
+          <a:ln>
+            <a:noFill/>
+          </a:ln>
+          <a:effectLst/>
+        </p:spPr>
+        <p:style>
+          <a:lnRef idx="1">
+            <a:schemeClr val="accent1"/>
+          </a:lnRef>
+          <a:fillRef idx="3">
+            <a:schemeClr val="accent1"/>
+          </a:fillRef>
+          <a:effectRef idx="2">
+            <a:schemeClr val="accent1"/>
+          </a:effectRef>
+          <a:fontRef idx="minor">
+            <a:schemeClr val="lt1"/>
+          </a:fontRef>
+        </p:style>
+        <p:txBody>
+          <a:bodyPr rtlCol="0" anchor="ctr"/>
+          <a:lstStyle/>
+          <a:p>
+            <a:pPr algn="ctr"/>
+          </a:p>
+        </p:txBody>
+      </p:sp>
+      <p:sp>
+        <p:nvSpPr>
+          <p:cNvPr id="11" name="Right Arrow 10"/>
+          <p:cNvSpPr/>
+          <p:nvPr/>
+        </p:nvSpPr>
+        <p:spPr>
+          <a:xfrm>
+            <a:off x="7110831" y="1668779"/>
+            <a:ext cx="256032" cy="182880"/>
+          </a:xfrm>
+          <a:prstGeom prst="rightArrow">
+            <a:avLst/>
+          </a:prstGeom>
+          <a:solidFill>
+            <a:srgbClr val="074D39"/>
+          </a:solidFill>
+          <a:ln>
+            <a:noFill/>
+          </a:ln>
+          <a:effectLst/>
+        </p:spPr>
+        <p:style>
+          <a:lnRef idx="1">
+            <a:schemeClr val="accent1"/>
+          </a:lnRef>
+          <a:fillRef idx="3">
+            <a:schemeClr val="accent1"/>
+          </a:fillRef>
+          <a:effectRef idx="2">
+            <a:schemeClr val="accent1"/>
+          </a:effectRef>
+          <a:fontRef idx="minor">
+            <a:schemeClr val="lt1"/>
+          </a:fontRef>
+        </p:style>
+        <p:txBody>
+          <a:bodyPr rtlCol="0" anchor="ctr"/>
+          <a:lstStyle/>
+          <a:p>
+            <a:pPr algn="ctr"/>
+          </a:p>
+        </p:txBody>
+      </p:sp>
+      <p:sp>
+        <p:nvSpPr>
+          <p:cNvPr id="12" name="Right Arrow 11"/>
+          <p:cNvSpPr/>
+          <p:nvPr/>
+        </p:nvSpPr>
+        <p:spPr>
+          <a:xfrm>
+            <a:off x="9396831" y="1668779"/>
+            <a:ext cx="256032" cy="182880"/>
+          </a:xfrm>
+          <a:prstGeom prst="rightArrow">
+            <a:avLst/>
+          </a:prstGeom>
+          <a:solidFill>
+            <a:srgbClr val="074D39"/>
+          </a:solidFill>
+          <a:ln>
+            <a:noFill/>
+          </a:ln>
+          <a:effectLst/>
+        </p:spPr>
+        <p:style>
+          <a:lnRef idx="1">
+            <a:schemeClr val="accent1"/>
+          </a:lnRef>
+          <a:fillRef idx="3">
+            <a:schemeClr val="accent1"/>
+          </a:fillRef>
+          <a:effectRef idx="2">
+            <a:schemeClr val="accent1"/>
+          </a:effectRef>
+          <a:fontRef idx="minor">
+            <a:schemeClr val="lt1"/>
+          </a:fontRef>
+        </p:style>
+        <p:txBody>
+          <a:bodyPr rtlCol="0" anchor="ctr"/>
+          <a:lstStyle/>
+          <a:p>
+            <a:pPr algn="ctr"/>
+          </a:p>
+        </p:txBody>
+      </p:sp>
+      <p:sp>
+        <p:nvSpPr>
+          <p:cNvPr id="13" name="Down Arrow 12"/>
+          <p:cNvSpPr/>
+          <p:nvPr/>
+        </p:nvSpPr>
+        <p:spPr>
+          <a:xfrm>
+            <a:off x="5995263" y="2240279"/>
+            <a:ext cx="201168" cy="365760"/>
+          </a:xfrm>
+          <a:prstGeom prst="downArrow">
+            <a:avLst/>
+          </a:prstGeom>
+          <a:solidFill>
+            <a:srgbClr val="074D39"/>
+          </a:solidFill>
+          <a:ln>
+            <a:noFill/>
+          </a:ln>
+          <a:effectLst/>
+        </p:spPr>
+        <p:style>
+          <a:lnRef idx="1">
+            <a:schemeClr val="accent1"/>
+          </a:lnRef>
+          <a:fillRef idx="3">
+            <a:schemeClr val="accent1"/>
+          </a:fillRef>
+          <a:effectRef idx="2">
+            <a:schemeClr val="accent1"/>
+          </a:effectRef>
+          <a:fontRef idx="minor">
+            <a:schemeClr val="lt1"/>
+          </a:fontRef>
+        </p:style>
+        <p:txBody>
+          <a:bodyPr rtlCol="0" anchor="ctr"/>
+          <a:lstStyle/>
+          <a:p>
+            <a:pPr algn="ctr"/>
+          </a:p>
+        </p:txBody>
+      </p:sp>
+      <p:sp>
+        <p:nvSpPr>
+          <p:cNvPr id="14" name="TextBox 13"/>
+          <p:cNvSpPr txBox="1"/>
+          <p:nvPr/>
+        </p:nvSpPr>
+        <p:spPr>
+          <a:xfrm>
+            <a:off x="6260439" y="2249424"/>
+            <a:ext cx="1463040" cy="274320"/>
+          </a:xfrm>
+          <a:prstGeom prst="rect">
+            <a:avLst/>
+          </a:prstGeom>
+          <a:noFill/>
+        </p:spPr>
+        <p:txBody>
+          <a:bodyPr wrap="square" anchor="t">
+            <a:spAutoFit/>
+          </a:bodyPr>
+          <a:lstStyle/>
+          <a:p>
+            <a:pPr algn="l">
+              <a:spcAft>
+                <a:spcPts val="600"/>
+              </a:spcAft>
+              <a:defRPr sz="1000" b="0">
+                <a:solidFill>
+                  <a:srgbClr val="5A6F63"/>
+                </a:solidFill>
+              </a:defRPr>
+            </a:pPr>
+            <a:r>
+              <a:t>export_model</a:t>
+            </a:r>
+          </a:p>
+        </p:txBody>
+      </p:sp>
+      <p:sp>
+        <p:nvSpPr>
+          <p:cNvPr id="15" name="Rounded Rectangle 14"/>
+          <p:cNvSpPr/>
+          <p:nvPr/>
+        </p:nvSpPr>
+        <p:spPr>
+          <a:xfrm>
+            <a:off x="2804007" y="2670048"/>
+            <a:ext cx="6583680" cy="658368"/>
+          </a:xfrm>
+          <a:prstGeom prst="roundRect">
+            <a:avLst/>
+          </a:prstGeom>
+          <a:solidFill>
+            <a:srgbClr val="CFE6D8"/>
+          </a:solidFill>
+          <a:ln w="15875">
+            <a:solidFill>
+              <a:srgbClr val="B6D2C1"/>
+            </a:solidFill>
+          </a:ln>
+          <a:effectLst/>
+        </p:spPr>
+        <p:style>
+          <a:lnRef idx="1">
+            <a:schemeClr val="accent1"/>
+          </a:lnRef>
+          <a:fillRef idx="3">
+            <a:schemeClr val="accent1"/>
+          </a:fillRef>
+          <a:effectRef idx="2">
+            <a:schemeClr val="accent1"/>
+          </a:effectRef>
+          <a:fontRef idx="minor">
+            <a:schemeClr val="lt1"/>
+          </a:fontRef>
+        </p:style>
+        <p:txBody>
+          <a:bodyPr rtlCol="0" anchor="ctr"/>
+          <a:lstStyle/>
+          <a:p>
+            <a:pPr algn="ctr">
+              <a:spcAft>
+                <a:spcPts val="600"/>
+              </a:spcAft>
+              <a:defRPr sz="1250" b="1">
+                <a:solidFill>
+                  <a:srgbClr val="074D39"/>
+                </a:solidFill>
+              </a:defRPr>
+            </a:pPr>
+            <a:r>
+              <a:t>artifacts/   model.joblib  ·  feature_spec.json  ·  drift_reference.parquet</a:t>
+            </a:r>
+          </a:p>
+        </p:txBody>
+      </p:sp>
+      <p:sp>
+        <p:nvSpPr>
+          <p:cNvPr id="16" name="Down Arrow 15"/>
+          <p:cNvSpPr/>
+          <p:nvPr/>
+        </p:nvSpPr>
+        <p:spPr>
+          <a:xfrm>
+            <a:off x="5995263" y="3383280"/>
+            <a:ext cx="201168" cy="365760"/>
+          </a:xfrm>
+          <a:prstGeom prst="downArrow">
+            <a:avLst/>
+          </a:prstGeom>
+          <a:solidFill>
+            <a:srgbClr val="074D39"/>
+          </a:solidFill>
+          <a:ln>
+            <a:noFill/>
+          </a:ln>
+          <a:effectLst/>
+        </p:spPr>
+        <p:style>
+          <a:lnRef idx="1">
+            <a:schemeClr val="accent1"/>
+          </a:lnRef>
+          <a:fillRef idx="3">
+            <a:schemeClr val="accent1"/>
+          </a:fillRef>
+          <a:effectRef idx="2">
+            <a:schemeClr val="accent1"/>
+          </a:effectRef>
+          <a:fontRef idx="minor">
+            <a:schemeClr val="lt1"/>
+          </a:fontRef>
+        </p:style>
+        <p:txBody>
+          <a:bodyPr rtlCol="0" anchor="ctr"/>
+          <a:lstStyle/>
+          <a:p>
+            <a:pPr algn="ctr"/>
+          </a:p>
+        </p:txBody>
+      </p:sp>
+      <p:sp>
+        <p:nvSpPr>
+          <p:cNvPr id="17" name="TextBox 16"/>
+          <p:cNvSpPr txBox="1"/>
+          <p:nvPr/>
+        </p:nvSpPr>
+        <p:spPr>
+          <a:xfrm>
+            <a:off x="530352" y="3822191"/>
+            <a:ext cx="7315200" cy="292608"/>
+          </a:xfrm>
+          <a:prstGeom prst="rect">
+            <a:avLst/>
+          </a:prstGeom>
+          <a:noFill/>
+        </p:spPr>
+        <p:txBody>
+          <a:bodyPr wrap="square" anchor="t">
+            <a:spAutoFit/>
+          </a:bodyPr>
+          <a:lstStyle/>
+          <a:p>
+            <a:pPr algn="l">
+              <a:spcAft>
+                <a:spcPts val="600"/>
+              </a:spcAft>
+              <a:defRPr sz="1300" b="1">
+                <a:solidFill>
+                  <a:srgbClr val="0B6B4F"/>
+                </a:solidFill>
+              </a:defRPr>
+            </a:pPr>
+            <a:r>
+              <a:t>ONLINE  —  serve  (FastAPI in Docker)</a:t>
+            </a:r>
+          </a:p>
+        </p:txBody>
+      </p:sp>
+      <p:sp>
+        <p:nvSpPr>
+          <p:cNvPr id="18" name="Rounded Rectangle 17"/>
+          <p:cNvSpPr/>
+          <p:nvPr/>
+        </p:nvSpPr>
+        <p:spPr>
+          <a:xfrm>
+            <a:off x="3901287" y="3840480"/>
+            <a:ext cx="4389120" cy="822960"/>
           </a:xfrm>
           <a:prstGeom prst="roundRect">
             <a:avLst/>
@@ -4579,12 +5015,12 @@
           </a:fontRef>
         </p:style>
         <p:txBody>
-          <a:bodyPr rtlCol="0" anchor="ctr" tIns="0" bIns="0"/>
+          <a:bodyPr rtlCol="0" anchor="ctr"/>
           <a:lstStyle/>
           <a:p>
             <a:pPr algn="ctr">
               <a:spcAft>
-                <a:spcPts val="200"/>
+                <a:spcPts val="100"/>
               </a:spcAft>
               <a:defRPr sz="1400" b="1">
                 <a:solidFill>
@@ -4593,13 +5029,13 @@
               </a:defRPr>
             </a:pPr>
             <a:r>
-              <a:t>Serve</a:t>
+              <a:t>Serve / predict</a:t>
             </a:r>
           </a:p>
           <a:p>
             <a:pPr algn="ctr">
               <a:spcAft>
-                <a:spcPts val="0"/>
+                <a:spcPts val="600"/>
               </a:spcAft>
               <a:defRPr sz="1000" b="0">
                 <a:solidFill>
@@ -4608,23 +5044,23 @@
               </a:defRPr>
             </a:pPr>
             <a:r>
-              <a:t>risk + SHAP</a:t>
-            </a:r>
-          </a:p>
-        </p:txBody>
-      </p:sp>
-      <p:sp>
-        <p:nvSpPr>
-          <p:cNvPr id="9" name="Right Arrow 8"/>
+              <a:t>featurize → model → risk + SHAP</a:t>
+            </a:r>
+          </a:p>
+        </p:txBody>
+      </p:sp>
+      <p:sp>
+        <p:nvSpPr>
+          <p:cNvPr id="19" name="Down Arrow 18"/>
           <p:cNvSpPr/>
           <p:nvPr/>
         </p:nvSpPr>
         <p:spPr>
           <a:xfrm>
-            <a:off x="2150211" y="2253996"/>
-            <a:ext cx="246888" cy="201168"/>
-          </a:xfrm>
-          <a:prstGeom prst="rightArrow">
+            <a:off x="5995263" y="4709160"/>
+            <a:ext cx="201168" cy="347472"/>
+          </a:xfrm>
+          <a:prstGeom prst="downArrow">
             <a:avLst/>
           </a:prstGeom>
           <a:solidFill>
@@ -4659,228 +5095,14 @@
       </p:sp>
       <p:sp>
         <p:nvSpPr>
-          <p:cNvPr id="10" name="Right Arrow 9"/>
+          <p:cNvPr id="20" name="Rounded Rectangle 19"/>
           <p:cNvSpPr/>
           <p:nvPr/>
         </p:nvSpPr>
         <p:spPr>
           <a:xfrm>
-            <a:off x="4061307" y="2253996"/>
-            <a:ext cx="246888" cy="201168"/>
-          </a:xfrm>
-          <a:prstGeom prst="rightArrow">
-            <a:avLst/>
-          </a:prstGeom>
-          <a:solidFill>
-            <a:srgbClr val="074D39"/>
-          </a:solidFill>
-          <a:ln>
-            <a:noFill/>
-          </a:ln>
-          <a:effectLst/>
-        </p:spPr>
-        <p:style>
-          <a:lnRef idx="1">
-            <a:schemeClr val="accent1"/>
-          </a:lnRef>
-          <a:fillRef idx="3">
-            <a:schemeClr val="accent1"/>
-          </a:fillRef>
-          <a:effectRef idx="2">
-            <a:schemeClr val="accent1"/>
-          </a:effectRef>
-          <a:fontRef idx="minor">
-            <a:schemeClr val="lt1"/>
-          </a:fontRef>
-        </p:style>
-        <p:txBody>
-          <a:bodyPr rtlCol="0" anchor="ctr"/>
-          <a:lstStyle/>
-          <a:p>
-            <a:pPr algn="ctr"/>
-          </a:p>
-        </p:txBody>
-      </p:sp>
-      <p:sp>
-        <p:nvSpPr>
-          <p:cNvPr id="11" name="Right Arrow 10"/>
-          <p:cNvSpPr/>
-          <p:nvPr/>
-        </p:nvSpPr>
-        <p:spPr>
-          <a:xfrm>
-            <a:off x="5972403" y="2253996"/>
-            <a:ext cx="246888" cy="201168"/>
-          </a:xfrm>
-          <a:prstGeom prst="rightArrow">
-            <a:avLst/>
-          </a:prstGeom>
-          <a:solidFill>
-            <a:srgbClr val="074D39"/>
-          </a:solidFill>
-          <a:ln>
-            <a:noFill/>
-          </a:ln>
-          <a:effectLst/>
-        </p:spPr>
-        <p:style>
-          <a:lnRef idx="1">
-            <a:schemeClr val="accent1"/>
-          </a:lnRef>
-          <a:fillRef idx="3">
-            <a:schemeClr val="accent1"/>
-          </a:fillRef>
-          <a:effectRef idx="2">
-            <a:schemeClr val="accent1"/>
-          </a:effectRef>
-          <a:fontRef idx="minor">
-            <a:schemeClr val="lt1"/>
-          </a:fontRef>
-        </p:style>
-        <p:txBody>
-          <a:bodyPr rtlCol="0" anchor="ctr"/>
-          <a:lstStyle/>
-          <a:p>
-            <a:pPr algn="ctr"/>
-          </a:p>
-        </p:txBody>
-      </p:sp>
-      <p:sp>
-        <p:nvSpPr>
-          <p:cNvPr id="12" name="Right Arrow 11"/>
-          <p:cNvSpPr/>
-          <p:nvPr/>
-        </p:nvSpPr>
-        <p:spPr>
-          <a:xfrm>
-            <a:off x="7883499" y="2253996"/>
-            <a:ext cx="246888" cy="201168"/>
-          </a:xfrm>
-          <a:prstGeom prst="rightArrow">
-            <a:avLst/>
-          </a:prstGeom>
-          <a:solidFill>
-            <a:srgbClr val="074D39"/>
-          </a:solidFill>
-          <a:ln>
-            <a:noFill/>
-          </a:ln>
-          <a:effectLst/>
-        </p:spPr>
-        <p:style>
-          <a:lnRef idx="1">
-            <a:schemeClr val="accent1"/>
-          </a:lnRef>
-          <a:fillRef idx="3">
-            <a:schemeClr val="accent1"/>
-          </a:fillRef>
-          <a:effectRef idx="2">
-            <a:schemeClr val="accent1"/>
-          </a:effectRef>
-          <a:fontRef idx="minor">
-            <a:schemeClr val="lt1"/>
-          </a:fontRef>
-        </p:style>
-        <p:txBody>
-          <a:bodyPr rtlCol="0" anchor="ctr"/>
-          <a:lstStyle/>
-          <a:p>
-            <a:pPr algn="ctr"/>
-          </a:p>
-        </p:txBody>
-      </p:sp>
-      <p:sp>
-        <p:nvSpPr>
-          <p:cNvPr id="13" name="Right Arrow 12"/>
-          <p:cNvSpPr/>
-          <p:nvPr/>
-        </p:nvSpPr>
-        <p:spPr>
-          <a:xfrm>
-            <a:off x="9794595" y="2253996"/>
-            <a:ext cx="246888" cy="201168"/>
-          </a:xfrm>
-          <a:prstGeom prst="rightArrow">
-            <a:avLst/>
-          </a:prstGeom>
-          <a:solidFill>
-            <a:srgbClr val="074D39"/>
-          </a:solidFill>
-          <a:ln>
-            <a:noFill/>
-          </a:ln>
-          <a:effectLst/>
-        </p:spPr>
-        <p:style>
-          <a:lnRef idx="1">
-            <a:schemeClr val="accent1"/>
-          </a:lnRef>
-          <a:fillRef idx="3">
-            <a:schemeClr val="accent1"/>
-          </a:fillRef>
-          <a:effectRef idx="2">
-            <a:schemeClr val="accent1"/>
-          </a:effectRef>
-          <a:fontRef idx="minor">
-            <a:schemeClr val="lt1"/>
-          </a:fontRef>
-        </p:style>
-        <p:txBody>
-          <a:bodyPr rtlCol="0" anchor="ctr"/>
-          <a:lstStyle/>
-          <a:p>
-            <a:pPr algn="ctr"/>
-          </a:p>
-        </p:txBody>
-      </p:sp>
-      <p:sp>
-        <p:nvSpPr>
-          <p:cNvPr id="14" name="TextBox 13"/>
-          <p:cNvSpPr txBox="1"/>
-          <p:nvPr/>
-        </p:nvSpPr>
-        <p:spPr>
-          <a:xfrm>
-            <a:off x="548640" y="3154680"/>
-            <a:ext cx="11064240" cy="457200"/>
-          </a:xfrm>
-          <a:prstGeom prst="rect">
-            <a:avLst/>
-          </a:prstGeom>
-          <a:noFill/>
-        </p:spPr>
-        <p:txBody>
-          <a:bodyPr wrap="square" anchor="t">
-            <a:spAutoFit/>
-          </a:bodyPr>
-          <a:lstStyle/>
-          <a:p>
-            <a:pPr algn="ctr">
-              <a:spcAft>
-                <a:spcPts val="600"/>
-              </a:spcAft>
-              <a:defRPr sz="1200" b="0">
-                <a:solidFill>
-                  <a:srgbClr val="5A6F63"/>
-                </a:solidFill>
-              </a:defRPr>
-            </a:pPr>
-            <a:r>
-              <a:t>Each stage's output is the next stage's input:  cleaned.parquet → features.parquet → MLflow model → artifacts/ → live predictions.</a:t>
-            </a:r>
-          </a:p>
-        </p:txBody>
-      </p:sp>
-      <p:sp>
-        <p:nvSpPr>
-          <p:cNvPr id="15" name="Rounded Rectangle 14"/>
-          <p:cNvSpPr/>
-          <p:nvPr/>
-        </p:nvSpPr>
-        <p:spPr>
-          <a:xfrm>
-            <a:off x="914400" y="4114800"/>
-            <a:ext cx="10360152" cy="1371600"/>
+            <a:off x="530352" y="5074920"/>
+            <a:ext cx="11128248" cy="1234440"/>
           </a:xfrm>
           <a:prstGeom prst="roundRect">
             <a:avLst/>
@@ -4910,7 +5132,7 @@
           </a:fontRef>
         </p:style>
         <p:txBody>
-          <a:bodyPr rtlCol="0" anchor="ctr" lIns="274320"/>
+          <a:bodyPr rtlCol="0" anchor="ctr"/>
           <a:lstStyle/>
           <a:p>
             <a:pPr algn="ctr">
@@ -4924,7 +5146,7 @@
               </a:defRPr>
             </a:pPr>
             <a:r>
-              <a:t>Monitoring &amp; Governance  (wraps the served model)</a:t>
+              <a:t>Monitoring &amp; Governance   (wraps the served model)</a:t>
             </a:r>
           </a:p>
           <a:p>
@@ -4932,59 +5154,15 @@
               <a:spcAft>
                 <a:spcPts val="600"/>
               </a:spcAft>
-              <a:defRPr sz="1300" b="0">
+              <a:defRPr sz="1250" b="0">
                 <a:solidFill>
                   <a:srgbClr val="16261D"/>
                 </a:solidFill>
               </a:defRPr>
             </a:pPr>
             <a:r>
-              <a:t>every prediction logged  →  drift · metrics · alerts   |   fairness · SHAP · model card · lineage</a:t>
-            </a:r>
-          </a:p>
-        </p:txBody>
-      </p:sp>
-      <p:sp>
-        <p:nvSpPr>
-          <p:cNvPr id="16" name="Down Arrow 15"/>
-          <p:cNvSpPr/>
-          <p:nvPr/>
-        </p:nvSpPr>
-        <p:spPr>
-          <a:xfrm>
-            <a:off x="10773003" y="2944368"/>
-            <a:ext cx="201168" cy="411480"/>
-          </a:xfrm>
-          <a:prstGeom prst="downArrow">
-            <a:avLst/>
-          </a:prstGeom>
-          <a:solidFill>
-            <a:srgbClr val="074D39"/>
-          </a:solidFill>
-          <a:ln>
-            <a:noFill/>
-          </a:ln>
-          <a:effectLst/>
-        </p:spPr>
-        <p:style>
-          <a:lnRef idx="1">
-            <a:schemeClr val="accent1"/>
-          </a:lnRef>
-          <a:fillRef idx="3">
-            <a:schemeClr val="accent1"/>
-          </a:fillRef>
-          <a:effectRef idx="2">
-            <a:schemeClr val="accent1"/>
-          </a:effectRef>
-          <a:fontRef idx="minor">
-            <a:schemeClr val="lt1"/>
-          </a:fontRef>
-        </p:style>
-        <p:txBody>
-          <a:bodyPr rtlCol="0" anchor="ctr"/>
-          <a:lstStyle/>
-          <a:p>
-            <a:pPr algn="ctr"/>
+              <a:t>every prediction logged  →  drift · metrics · alerts      |      fairness · SHAP · model card · lineage</a:t>
+            </a:r>
           </a:p>
         </p:txBody>
       </p:sp>

</xml_diff>